<commit_message>
Update report & presentation, add How to use guide in sidebar, sync patient data with sample reports
Made-with: Cursor
</commit_message>
<xml_diff>
--- a/MedGuardian_Presentation.pptx
+++ b/MedGuardian_Presentation.pptx
@@ -19,6 +19,8 @@
     <p:sldId id="267" r:id="rId13"/>
     <p:sldId id="268" r:id="rId14"/>
     <p:sldId id="269" r:id="rId15"/>
+    <p:sldId id="270" r:id="rId16"/>
+    <p:sldId id="271" r:id="rId17"/>
   </p:sldIdLst>
   <p:sldSz cx="9144000" cy="5143500" type="screen16x9"/>
   <p:notesSz cx="6858000" cy="9144000"/>
@@ -3151,7 +3153,7 @@
             </a:pPr>
             <a:r>
               <a:rPr b="1"/>
-              <a:t>AI Assisted Health Risk Insights</a:t>
+              <a:t>AI-Assisted Early Disease Detection System</a:t>
             </a:r>
           </a:p>
           <a:p>
@@ -3236,7 +3238,7 @@
             </a:pPr>
             <a:r>
               <a:rPr/>
-              <a:t>8. Demo &amp; Results</a:t>
+              <a:t>8. Datasets &amp; Sample Reports</a:t>
             </a:r>
           </a:p>
         </p:txBody>
@@ -3258,36 +3260,71 @@
           <a:p>
             <a:pPr lvl="0"/>
             <a:r>
-              <a:rPr/>
-              <a:t>Patient profile creation</a:t>
+              <a:rPr b="1"/>
+              <a:t>sample_patients.csv</a:t>
+            </a:r>
+            <a:r>
+              <a:rPr/>
+              <a:t> — 15 demo patients (aligned with report metadata)</a:t>
             </a:r>
           </a:p>
           <a:p>
             <a:pPr lvl="0"/>
             <a:r>
-              <a:rPr/>
-              <a:t>PDF upload and biomarker extraction</a:t>
+              <a:rPr b="1"/>
+              <a:t>sample_health_records.csv</a:t>
+            </a:r>
+            <a:r>
+              <a:rPr/>
+              <a:t> — 15 health records (one per patient)</a:t>
             </a:r>
           </a:p>
           <a:p>
             <a:pPr lvl="0"/>
             <a:r>
-              <a:rPr/>
-              <a:t>Risk dashboard with gauge charts</a:t>
+              <a:rPr b="1"/>
+              <a:t>15 PDF lab reports</a:t>
+            </a:r>
+            <a:r>
+              <a:rPr/>
+              <a:t> from </a:t>
+            </a:r>
+            <a:r>
+              <a:rPr b="1"/>
+              <a:t>5 laboratories</a:t>
+            </a:r>
+            <a:r>
+              <a:rPr/>
+              <a:t> (Care Diagnostics, Apollo, Thyro Lab, Metropolitan, Sunrise)</a:t>
             </a:r>
           </a:p>
           <a:p>
             <a:pPr lvl="0"/>
             <a:r>
-              <a:rPr/>
-              <a:t>History trends (Plotly)</a:t>
+              <a:rPr b="1"/>
+              <a:t>Age groups:</a:t>
+            </a:r>
+            <a:r>
+              <a:rPr/>
+              <a:t> 24–70 yrs (young adult to senior)</a:t>
             </a:r>
           </a:p>
           <a:p>
             <a:pPr lvl="0"/>
             <a:r>
-              <a:rPr/>
-              <a:t>Sample data loader for empty DB</a:t>
+              <a:rPr b="1"/>
+              <a:t>Risk profiles:</a:t>
+            </a:r>
+            <a:r>
+              <a:rPr/>
+              <a:t> 5 low, 5 moderate, 5 high</a:t>
+            </a:r>
+          </a:p>
+          <a:p>
+            <a:pPr lvl="0"/>
+            <a:r>
+              <a:rPr/>
+              <a:t>Load sample data from Home page when DB empty; Reset &amp; reload when needed</a:t>
             </a:r>
           </a:p>
         </p:txBody>
@@ -3334,7 +3371,69 @@
             </a:pPr>
             <a:r>
               <a:rPr/>
-              <a:t>9. Limitations</a:t>
+              <a:t>9. Demo &amp; Results</a:t>
+            </a:r>
+          </a:p>
+        </p:txBody>
+      </p:sp>
+      <p:pic>
+        <p:nvPicPr>
+          <p:cNvPr descr="screenshots/01_Login_Page.png" id="0" name="Picture 1"/>
+          <p:cNvPicPr>
+            <a:picLocks noGrp="1" noChangeAspect="1"/>
+          </p:cNvPicPr>
+          <p:nvPr/>
+        </p:nvPicPr>
+        <p:blipFill>
+          <a:blip r:embed="rId2"/>
+          <a:stretch>
+            <a:fillRect/>
+          </a:stretch>
+        </p:blipFill>
+        <p:spPr bwMode="auto">
+          <a:xfrm>
+            <a:off x="3060700" y="1193800"/>
+            <a:ext cx="3022600" cy="2882900"/>
+          </a:xfrm>
+          <a:prstGeom prst="rect">
+            <a:avLst/>
+          </a:prstGeom>
+          <a:noFill/>
+          <a:ln w="9525">
+            <a:noFill/>
+            <a:headEnd/>
+            <a:tailEnd/>
+          </a:ln>
+        </p:spPr>
+      </p:pic>
+      <p:sp>
+        <p:nvSpPr>
+          <p:cNvPr id="1" name="TextBox 3"/>
+          <p:cNvSpPr txBox="1"/>
+          <p:nvPr>
+            <p:ph idx="1"/>
+          </p:nvPr>
+        </p:nvSpPr>
+        <p:spPr>
+          <a:xfrm>
+            <a:off x="457200" y="4076700"/>
+            <a:ext cx="8229600" cy="508000"/>
+          </a:xfrm>
+          <a:prstGeom prst="rect">
+            <a:avLst/>
+          </a:prstGeom>
+          <a:noFill/>
+        </p:spPr>
+        <p:txBody>
+          <a:bodyPr/>
+          <a:lstStyle/>
+          <a:p>
+            <a:pPr lvl="0" indent="0" marL="0" algn="ctr">
+              <a:buNone/>
+            </a:pPr>
+            <a:r>
+              <a:rPr/>
+              <a:t>Login</a:t>
             </a:r>
           </a:p>
         </p:txBody>
@@ -3357,28 +3456,42 @@
             <a:pPr lvl="0"/>
             <a:r>
               <a:rPr/>
-              <a:t>Tesseract must be installed separately</a:t>
+              <a:t>Patient profile creation and CRUD</a:t>
             </a:r>
           </a:p>
           <a:p>
             <a:pPr lvl="0"/>
             <a:r>
               <a:rPr/>
-              <a:t>Single admin user</a:t>
+              <a:t>PDF upload → text extraction (pdfplumber / OCR)</a:t>
             </a:r>
           </a:p>
           <a:p>
             <a:pPr lvl="0"/>
             <a:r>
               <a:rPr/>
-              <a:t>Regex may not cover all lab formats</a:t>
+              <a:t>Biomarker parsing and user verification; Save Health Record → status: pending → processed</a:t>
             </a:r>
           </a:p>
           <a:p>
             <a:pPr lvl="0"/>
             <a:r>
               <a:rPr/>
-              <a:t>No EHR/API integration</a:t>
+              <a:t>Risk dashboard with gauge charts</a:t>
+            </a:r>
+          </a:p>
+          <a:p>
+            <a:pPr lvl="0"/>
+            <a:r>
+              <a:rPr/>
+              <a:t>History: risk trends, biomarker trends, uploaded reports (status: processed / pending / failed)</a:t>
+            </a:r>
+          </a:p>
+          <a:p>
+            <a:pPr lvl="0"/>
+            <a:r>
+              <a:rPr/>
+              <a:t>Sample data loader (15 patients, 15 records) for empty DB</a:t>
             </a:r>
           </a:p>
         </p:txBody>
@@ -3425,7 +3538,7 @@
             </a:pPr>
             <a:r>
               <a:rPr/>
-              <a:t>10. Future Work</a:t>
+              <a:t>10. Deployment (Git &amp; Streamlit Cloud)</a:t>
             </a:r>
           </a:p>
         </p:txBody>
@@ -3445,38 +3558,101 @@
           <a:bodyPr/>
           <a:lstStyle/>
           <a:p>
-            <a:pPr lvl="0"/>
-            <a:r>
-              <a:rPr/>
-              <a:t>More biomarkers (triglycerides, LDL, HDL)</a:t>
-            </a:r>
-          </a:p>
-          <a:p>
-            <a:pPr lvl="0"/>
-            <a:r>
-              <a:rPr/>
-              <a:t>Multi-user roles</a:t>
-            </a:r>
-          </a:p>
-          <a:p>
-            <a:pPr lvl="0"/>
-            <a:r>
-              <a:rPr/>
-              <a:t>Export to PDF</a:t>
-            </a:r>
-          </a:p>
-          <a:p>
-            <a:pPr lvl="0"/>
-            <a:r>
-              <a:rPr/>
-              <a:t>Cloud deployment (Streamlit Cloud)</a:t>
-            </a:r>
-          </a:p>
-          <a:p>
-            <a:pPr lvl="0"/>
-            <a:r>
-              <a:rPr/>
-              <a:t>Mobile responsiveness</a:t>
+            <a:pPr lvl="0" indent="0" marL="0">
+              <a:buNone/>
+            </a:pPr>
+            <a:r>
+              <a:rPr b="1"/>
+              <a:t>Git upload:</a:t>
+            </a:r>
+            <a:r>
+              <a:rPr/>
+              <a:t> </a:t>
+            </a:r>
+            <a:r>
+              <a:rPr>
+                <a:latin typeface="Courier"/>
+              </a:rPr>
+              <a:t>git init</a:t>
+            </a:r>
+            <a:r>
+              <a:rPr/>
+              <a:t> → </a:t>
+            </a:r>
+            <a:r>
+              <a:rPr>
+                <a:latin typeface="Courier"/>
+              </a:rPr>
+              <a:t>git add .</a:t>
+            </a:r>
+            <a:r>
+              <a:rPr/>
+              <a:t> → </a:t>
+            </a:r>
+            <a:r>
+              <a:rPr>
+                <a:latin typeface="Courier"/>
+              </a:rPr>
+              <a:t>git commit</a:t>
+            </a:r>
+            <a:r>
+              <a:rPr/>
+              <a:t> → </a:t>
+            </a:r>
+            <a:r>
+              <a:rPr>
+                <a:latin typeface="Courier"/>
+              </a:rPr>
+              <a:t>git remote add origin</a:t>
+            </a:r>
+            <a:r>
+              <a:rPr/>
+              <a:t> → </a:t>
+            </a:r>
+            <a:r>
+              <a:rPr>
+                <a:latin typeface="Courier"/>
+              </a:rPr>
+              <a:t>git push -u origin main</a:t>
+            </a:r>
+          </a:p>
+          <a:p>
+            <a:pPr lvl="0" indent="0" marL="0">
+              <a:buNone/>
+            </a:pPr>
+            <a:r>
+              <a:rPr b="1"/>
+              <a:t>Streamlit Cloud:</a:t>
+            </a:r>
+            <a:r>
+              <a:rPr/>
+              <a:t> Push to GitHub → share.streamlit.io → Create app → Select repo, main file path (</a:t>
+            </a:r>
+            <a:r>
+              <a:rPr>
+                <a:latin typeface="Courier"/>
+              </a:rPr>
+              <a:t>MedGuardian_Project/app.py</a:t>
+            </a:r>
+            <a:r>
+              <a:rPr/>
+              <a:t>) → Add secrets (</a:t>
+            </a:r>
+            <a:r>
+              <a:rPr>
+                <a:latin typeface="Courier"/>
+              </a:rPr>
+              <a:t>ADMIN_PASSWORD_HASH</a:t>
+            </a:r>
+            <a:r>
+              <a:rPr/>
+              <a:t>) → Deploy. App runs at </a:t>
+            </a:r>
+            <a:r>
+              <a:rPr>
+                <a:latin typeface="Courier"/>
+              </a:rPr>
+              <a:t>https://&lt;name&gt;.streamlit.app</a:t>
             </a:r>
           </a:p>
         </p:txBody>
@@ -3523,7 +3699,7 @@
             </a:pPr>
             <a:r>
               <a:rPr/>
-              <a:t>11. Conclusion</a:t>
+              <a:t>11. Limitations</a:t>
             </a:r>
           </a:p>
         </p:txBody>
@@ -3543,29 +3719,38 @@
           <a:bodyPr/>
           <a:lstStyle/>
           <a:p>
-            <a:pPr lvl="0" indent="0" marL="0">
-              <a:buNone/>
-            </a:pPr>
-            <a:r>
-              <a:rPr/>
-              <a:t>MedGuardian delivers an </a:t>
-            </a:r>
-            <a:r>
-              <a:rPr b="1"/>
-              <a:t>AI-assisted health risk insight</a:t>
-            </a:r>
-            <a:r>
-              <a:rPr/>
-              <a:t> system that: - Parses PDF lab reports (text + OCR) - Extracts biomarkers automatically - Computes clinically-grounded risk scores - Stores data locally in SQLite - Provides visualisation for trends</a:t>
-            </a:r>
-          </a:p>
-          <a:p>
-            <a:pPr lvl="0" indent="0" marL="0">
-              <a:buNone/>
-            </a:pPr>
-            <a:r>
-              <a:rPr b="1"/>
-              <a:t>Thank You</a:t>
+            <a:pPr lvl="0"/>
+            <a:r>
+              <a:rPr/>
+              <a:t>Tesseract must be installed separately; not available on Streamlit Cloud</a:t>
+            </a:r>
+          </a:p>
+          <a:p>
+            <a:pPr lvl="0"/>
+            <a:r>
+              <a:rPr/>
+              <a:t>Single admin user; no multi-tenancy</a:t>
+            </a:r>
+          </a:p>
+          <a:p>
+            <a:pPr lvl="0"/>
+            <a:r>
+              <a:rPr/>
+              <a:t>Regex may not cover all lab report formats</a:t>
+            </a:r>
+          </a:p>
+          <a:p>
+            <a:pPr lvl="0"/>
+            <a:r>
+              <a:rPr/>
+              <a:t>No EHR/LIS integration</a:t>
+            </a:r>
+          </a:p>
+          <a:p>
+            <a:pPr lvl="0"/>
+            <a:r>
+              <a:rPr/>
+              <a:t>Ephemeral DB on Streamlit Cloud; load sample data after each cold start</a:t>
             </a:r>
           </a:p>
         </p:txBody>
@@ -3612,6 +3797,193 @@
             </a:pPr>
             <a:r>
               <a:rPr/>
+              <a:t>12. Future Work</a:t>
+            </a:r>
+          </a:p>
+        </p:txBody>
+      </p:sp>
+      <p:sp>
+        <p:nvSpPr>
+          <p:cNvPr id="3" name="Content Placeholder 2"/>
+          <p:cNvSpPr>
+            <a:spLocks noGrp="1"/>
+          </p:cNvSpPr>
+          <p:nvPr>
+            <p:ph idx="1"/>
+          </p:nvPr>
+        </p:nvSpPr>
+        <p:spPr/>
+        <p:txBody>
+          <a:bodyPr/>
+          <a:lstStyle/>
+          <a:p>
+            <a:pPr lvl="0"/>
+            <a:r>
+              <a:rPr/>
+              <a:t>More biomarkers (triglycerides, LDL, HDL, creatinine)</a:t>
+            </a:r>
+          </a:p>
+          <a:p>
+            <a:pPr lvl="0"/>
+            <a:r>
+              <a:rPr/>
+              <a:t>Multi-user roles (admin, clinician, patient)</a:t>
+            </a:r>
+          </a:p>
+          <a:p>
+            <a:pPr lvl="0"/>
+            <a:r>
+              <a:rPr/>
+              <a:t>Export reports to PDF</a:t>
+            </a:r>
+          </a:p>
+          <a:p>
+            <a:pPr lvl="0"/>
+            <a:r>
+              <a:rPr/>
+              <a:t>Integration with lab information systems</a:t>
+            </a:r>
+          </a:p>
+          <a:p>
+            <a:pPr lvl="0"/>
+            <a:r>
+              <a:rPr/>
+              <a:t>Mobile responsiveness</a:t>
+            </a:r>
+          </a:p>
+        </p:txBody>
+      </p:sp>
+    </p:spTree>
+  </p:cSld>
+</p:sld>
+</file>
+
+<file path=ppt/slides/slide15.xml><?xml version="1.0" encoding="utf-8"?>
+<p:sld xmlns:a="http://schemas.openxmlformats.org/drawingml/2006/main" xmlns:r="http://schemas.openxmlformats.org/officeDocument/2006/relationships" xmlns:p="http://schemas.openxmlformats.org/presentationml/2006/main">
+  <p:cSld>
+    <p:spTree>
+      <p:nvGrpSpPr>
+        <p:cNvPr id="1" name=""/>
+        <p:cNvGrpSpPr/>
+        <p:nvPr/>
+      </p:nvGrpSpPr>
+      <p:grpSpPr>
+        <a:xfrm>
+          <a:off x="0" y="0"/>
+          <a:ext cx="0" cy="0"/>
+          <a:chOff x="0" y="0"/>
+          <a:chExt cx="0" cy="0"/>
+        </a:xfrm>
+      </p:grpSpPr>
+      <p:sp>
+        <p:nvSpPr>
+          <p:cNvPr id="2" name="Title 1"/>
+          <p:cNvSpPr>
+            <a:spLocks noGrp="1"/>
+          </p:cNvSpPr>
+          <p:nvPr>
+            <p:ph type="title"/>
+          </p:nvPr>
+        </p:nvSpPr>
+        <p:spPr/>
+        <p:txBody>
+          <a:bodyPr/>
+          <a:lstStyle/>
+          <a:p>
+            <a:pPr lvl="0" indent="0" marL="0">
+              <a:buNone/>
+            </a:pPr>
+            <a:r>
+              <a:rPr/>
+              <a:t>13. Conclusion</a:t>
+            </a:r>
+          </a:p>
+        </p:txBody>
+      </p:sp>
+      <p:sp>
+        <p:nvSpPr>
+          <p:cNvPr id="3" name="Content Placeholder 2"/>
+          <p:cNvSpPr>
+            <a:spLocks noGrp="1"/>
+          </p:cNvSpPr>
+          <p:nvPr>
+            <p:ph idx="1"/>
+          </p:nvPr>
+        </p:nvSpPr>
+        <p:spPr/>
+        <p:txBody>
+          <a:bodyPr/>
+          <a:lstStyle/>
+          <a:p>
+            <a:pPr lvl="0" indent="0" marL="0">
+              <a:buNone/>
+            </a:pPr>
+            <a:r>
+              <a:rPr/>
+              <a:t>MedGuardian delivers an </a:t>
+            </a:r>
+            <a:r>
+              <a:rPr b="1"/>
+              <a:t>AI-assisted early disease detection</a:t>
+            </a:r>
+            <a:r>
+              <a:rPr/>
+              <a:t> system that: - Parses PDF lab reports (text + OCR) - Extracts biomarkers automatically - Detects early disease risk (diabetes, hypertension, cholesterol) - Stores data in SQLite on deployment server - Provides gauge charts and trend visualisation - Supports 15 sample reports from 5 laboratories</a:t>
+            </a:r>
+          </a:p>
+          <a:p>
+            <a:pPr lvl="0" indent="0" marL="0">
+              <a:buNone/>
+            </a:pPr>
+            <a:r>
+              <a:rPr b="1"/>
+              <a:t>Thank You</a:t>
+            </a:r>
+          </a:p>
+        </p:txBody>
+      </p:sp>
+    </p:spTree>
+  </p:cSld>
+</p:sld>
+</file>
+
+<file path=ppt/slides/slide16.xml><?xml version="1.0" encoding="utf-8"?>
+<p:sld xmlns:a="http://schemas.openxmlformats.org/drawingml/2006/main" xmlns:r="http://schemas.openxmlformats.org/officeDocument/2006/relationships" xmlns:p="http://schemas.openxmlformats.org/presentationml/2006/main">
+  <p:cSld>
+    <p:spTree>
+      <p:nvGrpSpPr>
+        <p:cNvPr id="1" name=""/>
+        <p:cNvGrpSpPr/>
+        <p:nvPr/>
+      </p:nvGrpSpPr>
+      <p:grpSpPr>
+        <a:xfrm>
+          <a:off x="0" y="0"/>
+          <a:ext cx="0" cy="0"/>
+          <a:chOff x="0" y="0"/>
+          <a:chExt cx="0" cy="0"/>
+        </a:xfrm>
+      </p:grpSpPr>
+      <p:sp>
+        <p:nvSpPr>
+          <p:cNvPr id="2" name="Title 1"/>
+          <p:cNvSpPr>
+            <a:spLocks noGrp="1"/>
+          </p:cNvSpPr>
+          <p:nvPr>
+            <p:ph type="title"/>
+          </p:nvPr>
+        </p:nvSpPr>
+        <p:spPr/>
+        <p:txBody>
+          <a:bodyPr/>
+          <a:lstStyle/>
+          <a:p>
+            <a:pPr lvl="0" indent="0" marL="0">
+              <a:buNone/>
+            </a:pPr>
+            <a:r>
+              <a:rPr/>
               <a:t>Q &amp; A</a:t>
             </a:r>
           </a:p>
@@ -3785,7 +4157,25 @@
             </a:pPr>
             <a:r>
               <a:rPr/>
+              <a:t>Datasets &amp; Sample Reports</a:t>
+            </a:r>
+          </a:p>
+          <a:p>
+            <a:pPr lvl="0" indent="-342900" marL="342900">
+              <a:buAutoNum type="arabicPeriod"/>
+            </a:pPr>
+            <a:r>
+              <a:rPr/>
               <a:t>Demo &amp; Results</a:t>
+            </a:r>
+          </a:p>
+          <a:p>
+            <a:pPr lvl="0" indent="-342900" marL="342900">
+              <a:buAutoNum type="arabicPeriod"/>
+            </a:pPr>
+            <a:r>
+              <a:rPr/>
+              <a:t>Deployment (Git &amp; Streamlit Cloud)</a:t>
             </a:r>
           </a:p>
           <a:p>
@@ -3996,7 +4386,7 @@
             <a:pPr lvl="0"/>
             <a:r>
               <a:rPr/>
-              <a:t>Store data locally (no cloud dependency)</a:t>
+              <a:t>Data stored in SQLite on deployment server (no third-party analytics)</a:t>
             </a:r>
           </a:p>
         </p:txBody>
@@ -4066,7 +4456,7 @@
             <a:pPr lvl="0"/>
             <a:r>
               <a:rPr/>
-              <a:t>Build a Streamlit web app for health risk insights</a:t>
+              <a:t>Build a Streamlit web app for early disease detection</a:t>
             </a:r>
           </a:p>
           <a:p>
@@ -4638,7 +5028,7 @@
             </a:r>
             <a:r>
               <a:rPr/>
-              <a:t> (local database)</a:t>
+              <a:t> (on deployment server)</a:t>
             </a:r>
           </a:p>
           <a:p>

</xml_diff>